<commit_message>
added questions to the working groups
</commit_message>
<xml_diff>
--- a/ietf125-Shenzhen/slides/chair-slides-bmwg-ippm.pptx
+++ b/ietf125-Shenzhen/slides/chair-slides-bmwg-ippm.pptx
@@ -322,7 +322,7 @@
 <file path=ppt/revisionInfo.xml><?xml version="1.0" encoding="utf-8"?>
 <p1510:revInfo xmlns:a="http://schemas.openxmlformats.org/drawingml/2006/main" xmlns:r="http://schemas.openxmlformats.org/officeDocument/2006/relationships" xmlns:p1510="http://schemas.microsoft.com/office/powerpoint/2015/10/main">
   <p1510:revLst>
-    <p1510:client id="{BA3A2461-F736-466E-BB25-A64358F1D84B}" v="5" dt="2026-03-16T02:39:50.778"/>
+    <p1510:client id="{BA3A2461-F736-466E-BB25-A64358F1D84B}" v="8" dt="2026-03-16T02:54:35.503"/>
   </p1510:revLst>
 </p1510:revInfo>
 </file>
@@ -470,8 +470,8 @@
   </pc:docChgLst>
   <pc:docChgLst>
     <pc:chgData name="Graf Thomas, SCS-INI-NET-VNC-E2E" userId="487bc3e3-9ce7-4cdd-b7b4-8899ea88d289" providerId="ADAL" clId="{ADEEF08A-D719-4B50-A383-4105EDA2C206}"/>
-    <pc:docChg chg="custSel addSld delSld modSld sldOrd">
-      <pc:chgData name="Graf Thomas, SCS-INI-NET-VNC-E2E" userId="487bc3e3-9ce7-4cdd-b7b4-8899ea88d289" providerId="ADAL" clId="{ADEEF08A-D719-4B50-A383-4105EDA2C206}" dt="2026-03-16T02:40:37.316" v="585" actId="14100"/>
+    <pc:docChg chg="undo custSel addSld delSld modSld sldOrd">
+      <pc:chgData name="Graf Thomas, SCS-INI-NET-VNC-E2E" userId="487bc3e3-9ce7-4cdd-b7b4-8899ea88d289" providerId="ADAL" clId="{ADEEF08A-D719-4B50-A383-4105EDA2C206}" dt="2026-03-16T02:57:23.834" v="822" actId="14100"/>
       <pc:docMkLst>
         <pc:docMk/>
       </pc:docMkLst>
@@ -643,7 +643,7 @@
         </pc:spChg>
       </pc:sldChg>
       <pc:sldChg chg="addSp delSp modSp mod">
-        <pc:chgData name="Graf Thomas, SCS-INI-NET-VNC-E2E" userId="487bc3e3-9ce7-4cdd-b7b4-8899ea88d289" providerId="ADAL" clId="{ADEEF08A-D719-4B50-A383-4105EDA2C206}" dt="2026-03-08T10:31:18.398" v="334" actId="20577"/>
+        <pc:chgData name="Graf Thomas, SCS-INI-NET-VNC-E2E" userId="487bc3e3-9ce7-4cdd-b7b4-8899ea88d289" providerId="ADAL" clId="{ADEEF08A-D719-4B50-A383-4105EDA2C206}" dt="2026-03-16T02:57:23.834" v="822" actId="14100"/>
         <pc:sldMkLst>
           <pc:docMk/>
           <pc:sldMk cId="1859012803" sldId="271"/>
@@ -656,8 +656,16 @@
             <ac:spMk id="2" creationId="{0B9E15DC-F076-98D2-1BDF-BC01FEC9047B}"/>
           </ac:spMkLst>
         </pc:spChg>
+        <pc:spChg chg="add mod">
+          <ac:chgData name="Graf Thomas, SCS-INI-NET-VNC-E2E" userId="487bc3e3-9ce7-4cdd-b7b4-8899ea88d289" providerId="ADAL" clId="{ADEEF08A-D719-4B50-A383-4105EDA2C206}" dt="2026-03-16T02:57:23.834" v="822" actId="14100"/>
+          <ac:spMkLst>
+            <pc:docMk/>
+            <pc:sldMk cId="1859012803" sldId="271"/>
+            <ac:spMk id="3" creationId="{24D281E7-F8E0-9C4E-FACE-B48E30DA03D5}"/>
+          </ac:spMkLst>
+        </pc:spChg>
         <pc:picChg chg="add mod">
-          <ac:chgData name="Graf Thomas, SCS-INI-NET-VNC-E2E" userId="487bc3e3-9ce7-4cdd-b7b4-8899ea88d289" providerId="ADAL" clId="{ADEEF08A-D719-4B50-A383-4105EDA2C206}" dt="2026-03-08T10:31:08.868" v="312" actId="1076"/>
+          <ac:chgData name="Graf Thomas, SCS-INI-NET-VNC-E2E" userId="487bc3e3-9ce7-4cdd-b7b4-8899ea88d289" providerId="ADAL" clId="{ADEEF08A-D719-4B50-A383-4105EDA2C206}" dt="2026-03-16T02:56:34.681" v="811" actId="1076"/>
           <ac:picMkLst>
             <pc:docMk/>
             <pc:sldMk cId="1859012803" sldId="271"/>
@@ -702,6 +710,13 @@
             <ac:picMk id="5" creationId="{74860F62-55C1-B405-CE9E-8841E36880C9}"/>
           </ac:picMkLst>
         </pc:picChg>
+      </pc:sldChg>
+      <pc:sldChg chg="add del ord">
+        <pc:chgData name="Graf Thomas, SCS-INI-NET-VNC-E2E" userId="487bc3e3-9ce7-4cdd-b7b4-8899ea88d289" providerId="ADAL" clId="{ADEEF08A-D719-4B50-A383-4105EDA2C206}" dt="2026-03-16T02:52:04.115" v="589" actId="47"/>
+        <pc:sldMkLst>
+          <pc:docMk/>
+          <pc:sldMk cId="1432535309" sldId="275"/>
+        </pc:sldMkLst>
       </pc:sldChg>
     </pc:docChg>
   </pc:docChgLst>
@@ -29868,7 +29883,7 @@
         </p:blipFill>
         <p:spPr>
           <a:xfrm>
-            <a:off x="485462" y="2134400"/>
+            <a:off x="485462" y="1902581"/>
             <a:ext cx="8154538" cy="981212"/>
           </a:xfrm>
           <a:prstGeom prst="rect">
@@ -29876,6 +29891,410 @@
           </a:prstGeom>
         </p:spPr>
       </p:pic>
+      <p:sp>
+        <p:nvSpPr>
+          <p:cNvPr id="3" name="Google Shape;114;p21">
+            <a:extLst>
+              <a:ext uri="{FF2B5EF4-FFF2-40B4-BE49-F238E27FC236}">
+                <a16:creationId xmlns:a16="http://schemas.microsoft.com/office/drawing/2014/main" id="{24D281E7-F8E0-9C4E-FACE-B48E30DA03D5}"/>
+              </a:ext>
+            </a:extLst>
+          </p:cNvPr>
+          <p:cNvSpPr txBox="1">
+            <a:spLocks/>
+          </p:cNvSpPr>
+          <p:nvPr/>
+        </p:nvSpPr>
+        <p:spPr>
+          <a:xfrm>
+            <a:off x="309093" y="2962141"/>
+            <a:ext cx="8330907" cy="1494825"/>
+          </a:xfrm>
+          <a:prstGeom prst="rect">
+            <a:avLst/>
+          </a:prstGeom>
+          <a:noFill/>
+          <a:ln>
+            <a:noFill/>
+          </a:ln>
+        </p:spPr>
+        <p:txBody>
+          <a:bodyPr spcFirstLastPara="1" wrap="square" lIns="91425" tIns="91425" rIns="91425" bIns="91425" anchor="t" anchorCtr="0">
+            <a:noAutofit/>
+          </a:bodyPr>
+          <a:lstStyle>
+            <a:defPPr marR="0" lvl="0" algn="l" rtl="0">
+              <a:lnSpc>
+                <a:spcPct val="100000"/>
+              </a:lnSpc>
+              <a:spcBef>
+                <a:spcPts val="0"/>
+              </a:spcBef>
+              <a:spcAft>
+                <a:spcPts val="0"/>
+              </a:spcAft>
+            </a:defPPr>
+            <a:lvl1pPr marL="457200" marR="0" lvl="0" indent="-342900" algn="l" rtl="0">
+              <a:lnSpc>
+                <a:spcPct val="115000"/>
+              </a:lnSpc>
+              <a:spcBef>
+                <a:spcPts val="0"/>
+              </a:spcBef>
+              <a:spcAft>
+                <a:spcPts val="0"/>
+              </a:spcAft>
+              <a:buClr>
+                <a:srgbClr val="737373"/>
+              </a:buClr>
+              <a:buSzPts val="1800"/>
+              <a:buFont typeface="Montserrat"/>
+              <a:buChar char="●"/>
+              <a:defRPr sz="1800" b="0" i="0" u="none" strike="noStrike" cap="none">
+                <a:solidFill>
+                  <a:srgbClr val="737373"/>
+                </a:solidFill>
+                <a:latin typeface="Montserrat"/>
+                <a:ea typeface="Montserrat"/>
+                <a:cs typeface="Montserrat"/>
+                <a:sym typeface="Montserrat"/>
+              </a:defRPr>
+            </a:lvl1pPr>
+            <a:lvl2pPr marL="914400" marR="0" lvl="1" indent="-342900" algn="l" rtl="0">
+              <a:lnSpc>
+                <a:spcPct val="115000"/>
+              </a:lnSpc>
+              <a:spcBef>
+                <a:spcPts val="0"/>
+              </a:spcBef>
+              <a:spcAft>
+                <a:spcPts val="0"/>
+              </a:spcAft>
+              <a:buClr>
+                <a:srgbClr val="737373"/>
+              </a:buClr>
+              <a:buSzPts val="1800"/>
+              <a:buFont typeface="Montserrat"/>
+              <a:buChar char="○"/>
+              <a:defRPr sz="1800" b="0" i="0" u="none" strike="noStrike" cap="none">
+                <a:solidFill>
+                  <a:srgbClr val="737373"/>
+                </a:solidFill>
+                <a:latin typeface="Montserrat"/>
+                <a:ea typeface="Montserrat"/>
+                <a:cs typeface="Montserrat"/>
+                <a:sym typeface="Montserrat"/>
+              </a:defRPr>
+            </a:lvl2pPr>
+            <a:lvl3pPr marL="1371600" marR="0" lvl="2" indent="-342900" algn="l" rtl="0">
+              <a:lnSpc>
+                <a:spcPct val="115000"/>
+              </a:lnSpc>
+              <a:spcBef>
+                <a:spcPts val="0"/>
+              </a:spcBef>
+              <a:spcAft>
+                <a:spcPts val="0"/>
+              </a:spcAft>
+              <a:buClr>
+                <a:srgbClr val="737373"/>
+              </a:buClr>
+              <a:buSzPts val="1800"/>
+              <a:buFont typeface="Montserrat"/>
+              <a:buChar char="■"/>
+              <a:defRPr sz="1800" b="0" i="0" u="none" strike="noStrike" cap="none">
+                <a:solidFill>
+                  <a:srgbClr val="737373"/>
+                </a:solidFill>
+                <a:latin typeface="Montserrat"/>
+                <a:ea typeface="Montserrat"/>
+                <a:cs typeface="Montserrat"/>
+                <a:sym typeface="Montserrat"/>
+              </a:defRPr>
+            </a:lvl3pPr>
+            <a:lvl4pPr marL="1828800" marR="0" lvl="3" indent="-342900" algn="l" rtl="0">
+              <a:lnSpc>
+                <a:spcPct val="115000"/>
+              </a:lnSpc>
+              <a:spcBef>
+                <a:spcPts val="0"/>
+              </a:spcBef>
+              <a:spcAft>
+                <a:spcPts val="0"/>
+              </a:spcAft>
+              <a:buClr>
+                <a:srgbClr val="737373"/>
+              </a:buClr>
+              <a:buSzPts val="1800"/>
+              <a:buFont typeface="Montserrat"/>
+              <a:buChar char="●"/>
+              <a:defRPr sz="1800" b="0" i="0" u="none" strike="noStrike" cap="none">
+                <a:solidFill>
+                  <a:srgbClr val="737373"/>
+                </a:solidFill>
+                <a:latin typeface="Montserrat"/>
+                <a:ea typeface="Montserrat"/>
+                <a:cs typeface="Montserrat"/>
+                <a:sym typeface="Montserrat"/>
+              </a:defRPr>
+            </a:lvl4pPr>
+            <a:lvl5pPr marL="2286000" marR="0" lvl="4" indent="-342900" algn="l" rtl="0">
+              <a:lnSpc>
+                <a:spcPct val="115000"/>
+              </a:lnSpc>
+              <a:spcBef>
+                <a:spcPts val="0"/>
+              </a:spcBef>
+              <a:spcAft>
+                <a:spcPts val="0"/>
+              </a:spcAft>
+              <a:buClr>
+                <a:srgbClr val="737373"/>
+              </a:buClr>
+              <a:buSzPts val="1800"/>
+              <a:buFont typeface="Montserrat"/>
+              <a:buChar char="○"/>
+              <a:defRPr sz="1800" b="0" i="0" u="none" strike="noStrike" cap="none">
+                <a:solidFill>
+                  <a:srgbClr val="737373"/>
+                </a:solidFill>
+                <a:latin typeface="Montserrat"/>
+                <a:ea typeface="Montserrat"/>
+                <a:cs typeface="Montserrat"/>
+                <a:sym typeface="Montserrat"/>
+              </a:defRPr>
+            </a:lvl5pPr>
+            <a:lvl6pPr marL="2743200" marR="0" lvl="5" indent="-342900" algn="l" rtl="0">
+              <a:lnSpc>
+                <a:spcPct val="115000"/>
+              </a:lnSpc>
+              <a:spcBef>
+                <a:spcPts val="0"/>
+              </a:spcBef>
+              <a:spcAft>
+                <a:spcPts val="0"/>
+              </a:spcAft>
+              <a:buClr>
+                <a:srgbClr val="737373"/>
+              </a:buClr>
+              <a:buSzPts val="1800"/>
+              <a:buFont typeface="Montserrat"/>
+              <a:buChar char="■"/>
+              <a:defRPr sz="1800" b="0" i="0" u="none" strike="noStrike" cap="none">
+                <a:solidFill>
+                  <a:srgbClr val="737373"/>
+                </a:solidFill>
+                <a:latin typeface="Montserrat"/>
+                <a:ea typeface="Montserrat"/>
+                <a:cs typeface="Montserrat"/>
+                <a:sym typeface="Montserrat"/>
+              </a:defRPr>
+            </a:lvl6pPr>
+            <a:lvl7pPr marL="3200400" marR="0" lvl="6" indent="-342900" algn="l" rtl="0">
+              <a:lnSpc>
+                <a:spcPct val="115000"/>
+              </a:lnSpc>
+              <a:spcBef>
+                <a:spcPts val="0"/>
+              </a:spcBef>
+              <a:spcAft>
+                <a:spcPts val="0"/>
+              </a:spcAft>
+              <a:buClr>
+                <a:srgbClr val="737373"/>
+              </a:buClr>
+              <a:buSzPts val="1800"/>
+              <a:buFont typeface="Montserrat"/>
+              <a:buChar char="●"/>
+              <a:defRPr sz="1800" b="0" i="0" u="none" strike="noStrike" cap="none">
+                <a:solidFill>
+                  <a:srgbClr val="737373"/>
+                </a:solidFill>
+                <a:latin typeface="Montserrat"/>
+                <a:ea typeface="Montserrat"/>
+                <a:cs typeface="Montserrat"/>
+                <a:sym typeface="Montserrat"/>
+              </a:defRPr>
+            </a:lvl7pPr>
+            <a:lvl8pPr marL="3657600" marR="0" lvl="7" indent="-342900" algn="l" rtl="0">
+              <a:lnSpc>
+                <a:spcPct val="115000"/>
+              </a:lnSpc>
+              <a:spcBef>
+                <a:spcPts val="0"/>
+              </a:spcBef>
+              <a:spcAft>
+                <a:spcPts val="0"/>
+              </a:spcAft>
+              <a:buClr>
+                <a:srgbClr val="737373"/>
+              </a:buClr>
+              <a:buSzPts val="1800"/>
+              <a:buFont typeface="Montserrat"/>
+              <a:buChar char="○"/>
+              <a:defRPr sz="1800" b="0" i="0" u="none" strike="noStrike" cap="none">
+                <a:solidFill>
+                  <a:srgbClr val="737373"/>
+                </a:solidFill>
+                <a:latin typeface="Montserrat"/>
+                <a:ea typeface="Montserrat"/>
+                <a:cs typeface="Montserrat"/>
+                <a:sym typeface="Montserrat"/>
+              </a:defRPr>
+            </a:lvl8pPr>
+            <a:lvl9pPr marL="4114800" marR="0" lvl="8" indent="-342900" algn="l" rtl="0">
+              <a:lnSpc>
+                <a:spcPct val="115000"/>
+              </a:lnSpc>
+              <a:spcBef>
+                <a:spcPts val="0"/>
+              </a:spcBef>
+              <a:spcAft>
+                <a:spcPts val="0"/>
+              </a:spcAft>
+              <a:buClr>
+                <a:srgbClr val="737373"/>
+              </a:buClr>
+              <a:buSzPts val="1800"/>
+              <a:buFont typeface="Montserrat"/>
+              <a:buChar char="■"/>
+              <a:defRPr sz="1800" b="0" i="0" u="none" strike="noStrike" cap="none">
+                <a:solidFill>
+                  <a:srgbClr val="737373"/>
+                </a:solidFill>
+                <a:latin typeface="Montserrat"/>
+                <a:ea typeface="Montserrat"/>
+                <a:cs typeface="Montserrat"/>
+                <a:sym typeface="Montserrat"/>
+              </a:defRPr>
+            </a:lvl9pPr>
+          </a:lstStyle>
+          <a:p>
+            <a:pPr marL="146050" indent="0">
+              <a:spcBef>
+                <a:spcPts val="600"/>
+              </a:spcBef>
+              <a:buClr>
+                <a:srgbClr val="434343"/>
+              </a:buClr>
+              <a:buSzPts val="1300"/>
+              <a:buNone/>
+            </a:pPr>
+            <a:r>
+              <a:rPr lang="en-US" sz="1300" dirty="0">
+                <a:solidFill>
+                  <a:srgbClr val="434343"/>
+                </a:solidFill>
+                <a:latin typeface="Inter"/>
+                <a:ea typeface="Inter"/>
+                <a:cs typeface="Inter"/>
+                <a:sym typeface="Inter"/>
+              </a:rPr>
+              <a:t>We will raise the following questions to gather your feedback to help with the session planning and understanding the usefulness of the joint sessions.</a:t>
+            </a:r>
+          </a:p>
+          <a:p>
+            <a:pPr lvl="1" indent="-311150">
+              <a:spcBef>
+                <a:spcPts val="1800"/>
+              </a:spcBef>
+              <a:buClr>
+                <a:srgbClr val="434343"/>
+              </a:buClr>
+              <a:buSzPts val="1300"/>
+              <a:buFont typeface="Inter"/>
+              <a:buChar char="●"/>
+            </a:pPr>
+            <a:r>
+              <a:rPr lang="en-US" sz="1300" dirty="0">
+                <a:solidFill>
+                  <a:srgbClr val="434343"/>
+                </a:solidFill>
+                <a:latin typeface="Inter"/>
+                <a:ea typeface="Inter"/>
+                <a:cs typeface="Inter"/>
+                <a:sym typeface="Inter"/>
+              </a:rPr>
+              <a:t>Was there enough time for discussions?</a:t>
+            </a:r>
+          </a:p>
+          <a:p>
+            <a:pPr lvl="1" indent="-311150">
+              <a:spcBef>
+                <a:spcPts val="600"/>
+              </a:spcBef>
+              <a:buClr>
+                <a:srgbClr val="434343"/>
+              </a:buClr>
+              <a:buSzPts val="1300"/>
+              <a:buFont typeface="Inter"/>
+              <a:buChar char="●"/>
+            </a:pPr>
+            <a:r>
+              <a:rPr lang="en-US" sz="1300" dirty="0">
+                <a:solidFill>
+                  <a:srgbClr val="434343"/>
+                </a:solidFill>
+                <a:latin typeface="Inter"/>
+                <a:ea typeface="Inter"/>
+                <a:cs typeface="Inter"/>
+                <a:sym typeface="Inter"/>
+              </a:rPr>
+              <a:t>For your interested topics, was the time well spent?</a:t>
+            </a:r>
+          </a:p>
+          <a:p>
+            <a:pPr lvl="1" indent="-311150">
+              <a:spcBef>
+                <a:spcPts val="600"/>
+              </a:spcBef>
+              <a:buClr>
+                <a:srgbClr val="434343"/>
+              </a:buClr>
+              <a:buSzPts val="1300"/>
+              <a:buFont typeface="Inter"/>
+              <a:buChar char="●"/>
+            </a:pPr>
+            <a:r>
+              <a:rPr lang="en-US" sz="1300" dirty="0">
+                <a:solidFill>
+                  <a:srgbClr val="434343"/>
+                </a:solidFill>
+                <a:latin typeface="Inter"/>
+                <a:ea typeface="Inter"/>
+                <a:cs typeface="Inter"/>
+                <a:sym typeface="Inter"/>
+              </a:rPr>
+              <a:t>Should we allocate more time to proposed work?</a:t>
+            </a:r>
+          </a:p>
+          <a:p>
+            <a:pPr lvl="1" indent="-311150">
+              <a:spcBef>
+                <a:spcPts val="600"/>
+              </a:spcBef>
+              <a:buClr>
+                <a:srgbClr val="434343"/>
+              </a:buClr>
+              <a:buSzPts val="1300"/>
+              <a:buFont typeface="Inter"/>
+              <a:buChar char="●"/>
+            </a:pPr>
+            <a:r>
+              <a:rPr lang="en-US" sz="1300" dirty="0">
+                <a:solidFill>
+                  <a:srgbClr val="434343"/>
+                </a:solidFill>
+                <a:latin typeface="Inter"/>
+                <a:ea typeface="Inter"/>
+                <a:cs typeface="Inter"/>
+                <a:sym typeface="Inter"/>
+              </a:rPr>
+              <a:t>Did you cross review one or more documents?</a:t>
+            </a:r>
+          </a:p>
+        </p:txBody>
+      </p:sp>
     </p:spTree>
     <p:extLst>
       <p:ext uri="{BB962C8B-B14F-4D97-AF65-F5344CB8AC3E}">

</xml_diff>

<commit_message>
updated slides 9, 10 and 15
</commit_message>
<xml_diff>
--- a/ietf125-Shenzhen/slides/chair-slides-bmwg-ippm.pptx
+++ b/ietf125-Shenzhen/slides/chair-slides-bmwg-ippm.pptx
@@ -322,7 +322,7 @@
 <file path=ppt/revisionInfo.xml><?xml version="1.0" encoding="utf-8"?>
 <p1510:revInfo xmlns:a="http://schemas.openxmlformats.org/drawingml/2006/main" xmlns:r="http://schemas.openxmlformats.org/officeDocument/2006/relationships" xmlns:p1510="http://schemas.microsoft.com/office/powerpoint/2015/10/main">
   <p1510:revLst>
-    <p1510:client id="{BA3A2461-F736-466E-BB25-A64358F1D84B}" v="8" dt="2026-03-16T02:54:35.503"/>
+    <p1510:client id="{BA3A2461-F736-466E-BB25-A64358F1D84B}" v="16" dt="2026-03-17T03:54:52.658"/>
   </p1510:revLst>
 </p1510:revInfo>
 </file>
@@ -471,7 +471,7 @@
   <pc:docChgLst>
     <pc:chgData name="Graf Thomas, SCS-INI-NET-VNC-E2E" userId="487bc3e3-9ce7-4cdd-b7b4-8899ea88d289" providerId="ADAL" clId="{ADEEF08A-D719-4B50-A383-4105EDA2C206}"/>
     <pc:docChg chg="undo custSel addSld delSld modSld sldOrd">
-      <pc:chgData name="Graf Thomas, SCS-INI-NET-VNC-E2E" userId="487bc3e3-9ce7-4cdd-b7b4-8899ea88d289" providerId="ADAL" clId="{ADEEF08A-D719-4B50-A383-4105EDA2C206}" dt="2026-03-16T02:57:23.834" v="822" actId="14100"/>
+      <pc:chgData name="Graf Thomas, SCS-INI-NET-VNC-E2E" userId="487bc3e3-9ce7-4cdd-b7b4-8899ea88d289" providerId="ADAL" clId="{ADEEF08A-D719-4B50-A383-4105EDA2C206}" dt="2026-03-17T03:54:28.756" v="852" actId="6549"/>
       <pc:docMkLst>
         <pc:docMk/>
       </pc:docMkLst>
@@ -521,8 +521,8 @@
           </ac:spMkLst>
         </pc:spChg>
       </pc:sldChg>
-      <pc:sldChg chg="modSp mod">
-        <pc:chgData name="Graf Thomas, SCS-INI-NET-VNC-E2E" userId="487bc3e3-9ce7-4cdd-b7b4-8899ea88d289" providerId="ADAL" clId="{ADEEF08A-D719-4B50-A383-4105EDA2C206}" dt="2026-03-08T10:28:35.394" v="300" actId="20577"/>
+      <pc:sldChg chg="modSp mod modShow">
+        <pc:chgData name="Graf Thomas, SCS-INI-NET-VNC-E2E" userId="487bc3e3-9ce7-4cdd-b7b4-8899ea88d289" providerId="ADAL" clId="{ADEEF08A-D719-4B50-A383-4105EDA2C206}" dt="2026-03-17T03:50:27.260" v="849" actId="729"/>
         <pc:sldMkLst>
           <pc:docMk/>
           <pc:sldMk cId="0" sldId="260"/>
@@ -552,13 +552,21 @@
         </pc:spChg>
       </pc:sldChg>
       <pc:sldChg chg="addSp delSp modSp mod">
-        <pc:chgData name="Graf Thomas, SCS-INI-NET-VNC-E2E" userId="487bc3e3-9ce7-4cdd-b7b4-8899ea88d289" providerId="ADAL" clId="{ADEEF08A-D719-4B50-A383-4105EDA2C206}" dt="2026-03-08T10:30:12.315" v="304" actId="1076"/>
+        <pc:chgData name="Graf Thomas, SCS-INI-NET-VNC-E2E" userId="487bc3e3-9ce7-4cdd-b7b4-8899ea88d289" providerId="ADAL" clId="{ADEEF08A-D719-4B50-A383-4105EDA2C206}" dt="2026-03-17T03:35:05.713" v="827" actId="14100"/>
         <pc:sldMkLst>
           <pc:docMk/>
           <pc:sldMk cId="2332748115" sldId="263"/>
         </pc:sldMkLst>
         <pc:picChg chg="add mod">
-          <ac:chgData name="Graf Thomas, SCS-INI-NET-VNC-E2E" userId="487bc3e3-9ce7-4cdd-b7b4-8899ea88d289" providerId="ADAL" clId="{ADEEF08A-D719-4B50-A383-4105EDA2C206}" dt="2026-03-08T10:30:12.315" v="304" actId="1076"/>
+          <ac:chgData name="Graf Thomas, SCS-INI-NET-VNC-E2E" userId="487bc3e3-9ce7-4cdd-b7b4-8899ea88d289" providerId="ADAL" clId="{ADEEF08A-D719-4B50-A383-4105EDA2C206}" dt="2026-03-17T03:35:05.713" v="827" actId="14100"/>
+          <ac:picMkLst>
+            <pc:docMk/>
+            <pc:sldMk cId="2332748115" sldId="263"/>
+            <ac:picMk id="5" creationId="{7D9875EA-960F-77FB-E964-5AC1532E0964}"/>
+          </ac:picMkLst>
+        </pc:picChg>
+        <pc:picChg chg="add del mod">
+          <ac:chgData name="Graf Thomas, SCS-INI-NET-VNC-E2E" userId="487bc3e3-9ce7-4cdd-b7b4-8899ea88d289" providerId="ADAL" clId="{ADEEF08A-D719-4B50-A383-4105EDA2C206}" dt="2026-03-17T03:34:59.055" v="823" actId="478"/>
           <ac:picMkLst>
             <pc:docMk/>
             <pc:sldMk cId="2332748115" sldId="263"/>
@@ -567,22 +575,30 @@
         </pc:picChg>
       </pc:sldChg>
       <pc:sldChg chg="addSp delSp modSp mod">
-        <pc:chgData name="Graf Thomas, SCS-INI-NET-VNC-E2E" userId="487bc3e3-9ce7-4cdd-b7b4-8899ea88d289" providerId="ADAL" clId="{ADEEF08A-D719-4B50-A383-4105EDA2C206}" dt="2026-03-08T10:30:41.822" v="309" actId="1076"/>
+        <pc:chgData name="Graf Thomas, SCS-INI-NET-VNC-E2E" userId="487bc3e3-9ce7-4cdd-b7b4-8899ea88d289" providerId="ADAL" clId="{ADEEF08A-D719-4B50-A383-4105EDA2C206}" dt="2026-03-17T03:35:31.710" v="832" actId="14100"/>
         <pc:sldMkLst>
           <pc:docMk/>
           <pc:sldMk cId="703495152" sldId="264"/>
         </pc:sldMkLst>
-        <pc:picChg chg="add mod">
-          <ac:chgData name="Graf Thomas, SCS-INI-NET-VNC-E2E" userId="487bc3e3-9ce7-4cdd-b7b4-8899ea88d289" providerId="ADAL" clId="{ADEEF08A-D719-4B50-A383-4105EDA2C206}" dt="2026-03-08T10:30:41.822" v="309" actId="1076"/>
+        <pc:picChg chg="add del mod">
+          <ac:chgData name="Graf Thomas, SCS-INI-NET-VNC-E2E" userId="487bc3e3-9ce7-4cdd-b7b4-8899ea88d289" providerId="ADAL" clId="{ADEEF08A-D719-4B50-A383-4105EDA2C206}" dt="2026-03-17T03:35:22.297" v="828" actId="478"/>
           <ac:picMkLst>
             <pc:docMk/>
             <pc:sldMk cId="703495152" sldId="264"/>
             <ac:picMk id="5" creationId="{2A7C2331-189C-8472-D7A5-7462F6F8EE24}"/>
           </ac:picMkLst>
         </pc:picChg>
+        <pc:picChg chg="add mod">
+          <ac:chgData name="Graf Thomas, SCS-INI-NET-VNC-E2E" userId="487bc3e3-9ce7-4cdd-b7b4-8899ea88d289" providerId="ADAL" clId="{ADEEF08A-D719-4B50-A383-4105EDA2C206}" dt="2026-03-17T03:35:31.710" v="832" actId="14100"/>
+          <ac:picMkLst>
+            <pc:docMk/>
+            <pc:sldMk cId="703495152" sldId="264"/>
+            <ac:picMk id="6" creationId="{6C42BB47-46B8-24B3-E7FC-8D01301DFE79}"/>
+          </ac:picMkLst>
+        </pc:picChg>
       </pc:sldChg>
       <pc:sldChg chg="modSp mod">
-        <pc:chgData name="Graf Thomas, SCS-INI-NET-VNC-E2E" userId="487bc3e3-9ce7-4cdd-b7b4-8899ea88d289" providerId="ADAL" clId="{ADEEF08A-D719-4B50-A383-4105EDA2C206}" dt="2026-03-08T10:28:16.563" v="285" actId="20577"/>
+        <pc:chgData name="Graf Thomas, SCS-INI-NET-VNC-E2E" userId="487bc3e3-9ce7-4cdd-b7b4-8899ea88d289" providerId="ADAL" clId="{ADEEF08A-D719-4B50-A383-4105EDA2C206}" dt="2026-03-17T03:51:31.613" v="851" actId="14100"/>
         <pc:sldMkLst>
           <pc:docMk/>
           <pc:sldMk cId="1372742302" sldId="266"/>
@@ -596,7 +612,7 @@
           </ac:spMkLst>
         </pc:spChg>
         <pc:spChg chg="mod">
-          <ac:chgData name="Graf Thomas, SCS-INI-NET-VNC-E2E" userId="487bc3e3-9ce7-4cdd-b7b4-8899ea88d289" providerId="ADAL" clId="{ADEEF08A-D719-4B50-A383-4105EDA2C206}" dt="2026-03-08T10:28:16.563" v="285" actId="20577"/>
+          <ac:chgData name="Graf Thomas, SCS-INI-NET-VNC-E2E" userId="487bc3e3-9ce7-4cdd-b7b4-8899ea88d289" providerId="ADAL" clId="{ADEEF08A-D719-4B50-A383-4105EDA2C206}" dt="2026-03-17T03:51:31.613" v="851" actId="14100"/>
           <ac:spMkLst>
             <pc:docMk/>
             <pc:sldMk cId="1372742302" sldId="266"/>
@@ -605,7 +621,7 @@
         </pc:spChg>
       </pc:sldChg>
       <pc:sldChg chg="modSp mod">
-        <pc:chgData name="Graf Thomas, SCS-INI-NET-VNC-E2E" userId="487bc3e3-9ce7-4cdd-b7b4-8899ea88d289" providerId="ADAL" clId="{ADEEF08A-D719-4B50-A383-4105EDA2C206}" dt="2026-03-08T10:28:26.255" v="291" actId="20577"/>
+        <pc:chgData name="Graf Thomas, SCS-INI-NET-VNC-E2E" userId="487bc3e3-9ce7-4cdd-b7b4-8899ea88d289" providerId="ADAL" clId="{ADEEF08A-D719-4B50-A383-4105EDA2C206}" dt="2026-03-17T03:54:28.756" v="852" actId="6549"/>
         <pc:sldMkLst>
           <pc:docMk/>
           <pc:sldMk cId="2128497270" sldId="269"/>
@@ -619,7 +635,7 @@
           </ac:spMkLst>
         </pc:spChg>
         <pc:spChg chg="mod">
-          <ac:chgData name="Graf Thomas, SCS-INI-NET-VNC-E2E" userId="487bc3e3-9ce7-4cdd-b7b4-8899ea88d289" providerId="ADAL" clId="{ADEEF08A-D719-4B50-A383-4105EDA2C206}" dt="2026-03-08T10:28:26.255" v="291" actId="20577"/>
+          <ac:chgData name="Graf Thomas, SCS-INI-NET-VNC-E2E" userId="487bc3e3-9ce7-4cdd-b7b4-8899ea88d289" providerId="ADAL" clId="{ADEEF08A-D719-4B50-A383-4105EDA2C206}" dt="2026-03-17T03:54:28.756" v="852" actId="6549"/>
           <ac:spMkLst>
             <pc:docMk/>
             <pc:sldMk cId="2128497270" sldId="269"/>
@@ -29731,10 +29747,10 @@
       </p:sp>
       <p:pic>
         <p:nvPicPr>
-          <p:cNvPr id="5" name="Picture 4">
+          <p:cNvPr id="6" name="Picture 5">
             <a:extLst>
               <a:ext uri="{FF2B5EF4-FFF2-40B4-BE49-F238E27FC236}">
-                <a16:creationId xmlns:a16="http://schemas.microsoft.com/office/drawing/2014/main" id="{2A7C2331-189C-8472-D7A5-7462F6F8EE24}"/>
+                <a16:creationId xmlns:a16="http://schemas.microsoft.com/office/drawing/2014/main" id="{6C42BB47-46B8-24B3-E7FC-8D01301DFE79}"/>
               </a:ext>
             </a:extLst>
           </p:cNvPr>
@@ -29751,8 +29767,8 @@
         </p:blipFill>
         <p:spPr>
           <a:xfrm>
-            <a:off x="471900" y="2099886"/>
-            <a:ext cx="6383106" cy="2432016"/>
+            <a:off x="471900" y="1882967"/>
+            <a:ext cx="6022941" cy="2959489"/>
           </a:xfrm>
           <a:prstGeom prst="rect">
             <a:avLst/>
@@ -30634,13 +30650,18 @@
         <p:spPr>
           <a:xfrm>
             <a:off x="471900" y="1919074"/>
-            <a:ext cx="8222100" cy="2710201"/>
+            <a:ext cx="8395008" cy="2710201"/>
           </a:xfrm>
         </p:spPr>
         <p:txBody>
           <a:bodyPr/>
           <a:lstStyle/>
           <a:p>
+            <a:pPr>
+              <a:spcBef>
+                <a:spcPts val="1200"/>
+              </a:spcBef>
+            </a:pPr>
             <a:r>
               <a:rPr lang="de-CH" sz="1400" b="1" dirty="0">
                 <a:hlinkClick r:id="rId3"/>
@@ -30658,6 +30679,11 @@
             <a:endParaRPr lang="de-CH" sz="1200" dirty="0"/>
           </a:p>
           <a:p>
+            <a:pPr>
+              <a:spcBef>
+                <a:spcPts val="1200"/>
+              </a:spcBef>
+            </a:pPr>
             <a:r>
               <a:rPr lang="de-CH" sz="1400" b="1" dirty="0">
                 <a:hlinkClick r:id="rId4"/>
@@ -30670,13 +30696,22 @@
             </a:r>
           </a:p>
           <a:p>
-            <a:pPr lvl="1"/>
+            <a:pPr lvl="1">
+              <a:spcBef>
+                <a:spcPts val="1200"/>
+              </a:spcBef>
+            </a:pPr>
             <a:r>
               <a:rPr lang="de-CH" sz="1200" dirty="0"/>
               <a:t>New revision in preparation to address the Yangdoctors review</a:t>
             </a:r>
           </a:p>
           <a:p>
+            <a:pPr>
+              <a:spcBef>
+                <a:spcPts val="1200"/>
+              </a:spcBef>
+            </a:pPr>
             <a:r>
               <a:rPr lang="de-CH" sz="1400" b="1" dirty="0">
                 <a:hlinkClick r:id="rId5"/>
@@ -30689,6 +30724,11 @@
             </a:r>
           </a:p>
           <a:p>
+            <a:pPr>
+              <a:spcBef>
+                <a:spcPts val="1200"/>
+              </a:spcBef>
+            </a:pPr>
             <a:r>
               <a:rPr lang="de-CH" sz="1400" b="1" dirty="0">
                 <a:hlinkClick r:id="rId6"/>
@@ -30711,12 +30751,22 @@
             </a:r>
           </a:p>
           <a:p>
+            <a:pPr>
+              <a:spcBef>
+                <a:spcPts val="1200"/>
+              </a:spcBef>
+            </a:pPr>
             <a:r>
               <a:rPr lang="de-CH" sz="1400" dirty="0"/>
               <a:t>To resume the discussion for revisiting BMWG RFCs in order to update RFC 2544</a:t>
             </a:r>
           </a:p>
           <a:p>
+            <a:pPr>
+              <a:spcBef>
+                <a:spcPts val="1200"/>
+              </a:spcBef>
+            </a:pPr>
             <a:r>
               <a:rPr lang="en-US" sz="1400" dirty="0"/>
               <a:t>Rechartering to include new work on AI (either for a joint future with IPPM or separately)</a:t>
@@ -31061,8 +31111,163 @@
               </a:spcBef>
             </a:pPr>
             <a:r>
-              <a:rPr lang="en-US" sz="1500" b="1" dirty="0"/>
-              <a:t>TBD</a:t>
+              <a:rPr lang="en-US" sz="1400" dirty="0">
+                <a:hlinkClick r:id="rId3"/>
+              </a:rPr>
+              <a:t>draft-</a:t>
+            </a:r>
+            <a:r>
+              <a:rPr lang="en-US" sz="1400" dirty="0" err="1">
+                <a:hlinkClick r:id="rId3"/>
+              </a:rPr>
+              <a:t>ietf</a:t>
+            </a:r>
+            <a:r>
+              <a:rPr lang="en-US" sz="1400" dirty="0">
+                <a:hlinkClick r:id="rId3"/>
+              </a:rPr>
+              <a:t>-ippm-asymmetrical-pkts</a:t>
+            </a:r>
+            <a:r>
+              <a:rPr lang="en-US" sz="1400" dirty="0"/>
+              <a:t> received IESG comments which were addressed in -13.</a:t>
+            </a:r>
+          </a:p>
+          <a:p>
+            <a:pPr>
+              <a:spcBef>
+                <a:spcPts val="1200"/>
+              </a:spcBef>
+            </a:pPr>
+            <a:r>
+              <a:rPr lang="en-US" sz="1400" dirty="0">
+                <a:hlinkClick r:id="rId4"/>
+              </a:rPr>
+              <a:t>draft-ietf-ippm-qoo-07</a:t>
+            </a:r>
+            <a:r>
+              <a:rPr lang="en-US" sz="1400" dirty="0"/>
+              <a:t> received reviews from TSVART, ARTART, SECDIR and GENART. Authors are currently working on addressing the comments.</a:t>
+            </a:r>
+          </a:p>
+          <a:p>
+            <a:pPr>
+              <a:spcBef>
+                <a:spcPts val="1200"/>
+              </a:spcBef>
+            </a:pPr>
+            <a:r>
+              <a:rPr lang="en-US" sz="1400" dirty="0">
+                <a:hlinkClick r:id="rId5"/>
+              </a:rPr>
+              <a:t>draft-ietf-ippm-ioam-integrity-yang-05</a:t>
+            </a:r>
+            <a:r>
+              <a:rPr lang="en-US" sz="1400" dirty="0"/>
+              <a:t> working group last call </a:t>
+            </a:r>
+            <a:r>
+              <a:rPr lang="en-US" sz="1400" dirty="0">
+                <a:hlinkClick r:id="rId6"/>
+              </a:rPr>
+              <a:t>currently running</a:t>
+            </a:r>
+            <a:r>
+              <a:rPr lang="en-US" sz="1400" dirty="0"/>
+              <a:t>. </a:t>
+            </a:r>
+            <a:r>
+              <a:rPr lang="en-US" sz="1400" b="1" dirty="0"/>
+              <a:t>We need more feedback from both working groups </a:t>
+            </a:r>
+            <a:r>
+              <a:rPr lang="en-US" sz="1400" dirty="0"/>
+              <a:t>and want to progress </a:t>
+            </a:r>
+            <a:r>
+              <a:rPr lang="en-US" sz="1400" dirty="0">
+                <a:hlinkClick r:id="rId7"/>
+              </a:rPr>
+              <a:t>draft-</a:t>
+            </a:r>
+            <a:r>
+              <a:rPr lang="en-US" sz="1400" dirty="0" err="1">
+                <a:hlinkClick r:id="rId7"/>
+              </a:rPr>
+              <a:t>ietf</a:t>
+            </a:r>
+            <a:r>
+              <a:rPr lang="en-US" sz="1400" dirty="0">
+                <a:hlinkClick r:id="rId7"/>
+              </a:rPr>
+              <a:t>-ippm-</a:t>
+            </a:r>
+            <a:r>
+              <a:rPr lang="en-US" sz="1400" dirty="0" err="1">
+                <a:hlinkClick r:id="rId7"/>
+              </a:rPr>
+              <a:t>ioam</a:t>
+            </a:r>
+            <a:r>
+              <a:rPr lang="en-US" sz="1400" dirty="0">
+                <a:hlinkClick r:id="rId7"/>
+              </a:rPr>
+              <a:t>-data-integrity</a:t>
+            </a:r>
+            <a:r>
+              <a:rPr lang="en-US" sz="1400" dirty="0"/>
+              <a:t> and </a:t>
+            </a:r>
+            <a:r>
+              <a:rPr lang="en-US" sz="1400" dirty="0">
+                <a:hlinkClick r:id="rId8"/>
+              </a:rPr>
+              <a:t>draft-</a:t>
+            </a:r>
+            <a:r>
+              <a:rPr lang="en-US" sz="1400" dirty="0" err="1">
+                <a:hlinkClick r:id="rId8"/>
+              </a:rPr>
+              <a:t>ietf</a:t>
+            </a:r>
+            <a:r>
+              <a:rPr lang="en-US" sz="1400" dirty="0">
+                <a:hlinkClick r:id="rId8"/>
+              </a:rPr>
+              <a:t>-ippm-</a:t>
+            </a:r>
+            <a:r>
+              <a:rPr lang="en-US" sz="1400" dirty="0" err="1">
+                <a:hlinkClick r:id="rId8"/>
+              </a:rPr>
+              <a:t>ioam</a:t>
+            </a:r>
+            <a:r>
+              <a:rPr lang="en-US" sz="1400" dirty="0">
+                <a:hlinkClick r:id="rId8"/>
+              </a:rPr>
+              <a:t>-integrity-yang</a:t>
+            </a:r>
+            <a:r>
+              <a:rPr lang="en-US" sz="1400" dirty="0"/>
+              <a:t> at the same time through IESG.</a:t>
+            </a:r>
+          </a:p>
+          <a:p>
+            <a:pPr>
+              <a:spcBef>
+                <a:spcPts val="1200"/>
+              </a:spcBef>
+            </a:pPr>
+            <a:r>
+              <a:rPr lang="en-US" sz="1400" dirty="0">
+                <a:hlinkClick r:id="rId9"/>
+              </a:rPr>
+              <a:t>draft-ietf-ippm-encrypted-pdmv2</a:t>
+            </a:r>
+            <a:r>
+              <a:rPr lang="en-US" sz="1400" dirty="0"/>
+              <a:t> authors published -13 and intend to reach-out to the TSVART and GENART reviewers to clarify wherever the document update addressed their comments and request feedback from IPPM/BMWG/6MAN.</a:t>
             </a:r>
             <a:endParaRPr lang="en-US" dirty="0"/>
           </a:p>
@@ -31082,7 +31287,7 @@
 </file>
 
 <file path=ppt/slides/slide16.xml><?xml version="1.0" encoding="utf-8"?>
-<p:sld xmlns:a="http://schemas.openxmlformats.org/drawingml/2006/main" xmlns:r="http://schemas.openxmlformats.org/officeDocument/2006/relationships" xmlns:p="http://schemas.openxmlformats.org/presentationml/2006/main" show="0">
+<p:sld xmlns:a="http://schemas.openxmlformats.org/drawingml/2006/main" xmlns:r="http://schemas.openxmlformats.org/officeDocument/2006/relationships" xmlns:p="http://schemas.openxmlformats.org/presentationml/2006/main">
   <p:cSld>
     <p:spTree>
       <p:nvGrpSpPr>
@@ -34337,10 +34542,10 @@
       </p:sp>
       <p:pic>
         <p:nvPicPr>
-          <p:cNvPr id="6" name="Picture 5">
+          <p:cNvPr id="5" name="Picture 4">
             <a:extLst>
               <a:ext uri="{FF2B5EF4-FFF2-40B4-BE49-F238E27FC236}">
-                <a16:creationId xmlns:a16="http://schemas.microsoft.com/office/drawing/2014/main" id="{1BE5F7A4-628B-DDA9-A72D-3012CFAB2A25}"/>
+                <a16:creationId xmlns:a16="http://schemas.microsoft.com/office/drawing/2014/main" id="{7D9875EA-960F-77FB-E964-5AC1532E0964}"/>
               </a:ext>
             </a:extLst>
           </p:cNvPr>
@@ -34357,8 +34562,8 @@
         </p:blipFill>
         <p:spPr>
           <a:xfrm>
-            <a:off x="471900" y="1875974"/>
-            <a:ext cx="5273328" cy="2965863"/>
+            <a:off x="471901" y="1793818"/>
+            <a:ext cx="4808438" cy="3142915"/>
           </a:xfrm>
           <a:prstGeom prst="rect">
             <a:avLst/>
@@ -35802,16 +36007,16 @@
 <file path=customXml/itemProps3.xml><?xml version="1.0" encoding="utf-8"?>
 <ds:datastoreItem xmlns:ds="http://schemas.openxmlformats.org/officeDocument/2006/customXml" ds:itemID="{3D7021EF-4D3D-4708-92FB-F2CD02CEF7A1}">
   <ds:schemaRefs>
-    <ds:schemaRef ds:uri="http://schemas.openxmlformats.org/package/2006/metadata/core-properties"/>
-    <ds:schemaRef ds:uri="http://schemas.microsoft.com/office/2006/documentManagement/types"/>
-    <ds:schemaRef ds:uri="http://schemas.microsoft.com/office/infopath/2007/PartnerControls"/>
     <ds:schemaRef ds:uri="http://purl.org/dc/elements/1.1/"/>
-    <ds:schemaRef ds:uri="http://schemas.microsoft.com/office/2006/metadata/properties"/>
     <ds:schemaRef ds:uri="3e5e162a-5953-4fde-83b3-9639e6ab13bb"/>
     <ds:schemaRef ds:uri="266fa233-377d-43d6-82a1-e70154e55ff7"/>
     <ds:schemaRef ds:uri="http://purl.org/dc/terms/"/>
+    <ds:schemaRef ds:uri="http://purl.org/dc/dcmitype/"/>
+    <ds:schemaRef ds:uri="http://schemas.microsoft.com/office/infopath/2007/PartnerControls"/>
+    <ds:schemaRef ds:uri="http://schemas.microsoft.com/office/2006/documentManagement/types"/>
+    <ds:schemaRef ds:uri="http://schemas.openxmlformats.org/package/2006/metadata/core-properties"/>
+    <ds:schemaRef ds:uri="http://schemas.microsoft.com/office/2006/metadata/properties"/>
     <ds:schemaRef ds:uri="http://www.w3.org/XML/1998/namespace"/>
-    <ds:schemaRef ds:uri="http://purl.org/dc/dcmitype/"/>
   </ds:schemaRefs>
 </ds:datastoreItem>
 </file>

</xml_diff>